<commit_message>
docs: fixed some typos in final-presentation
</commit_message>
<xml_diff>
--- a/docs/final-presentation.pptx
+++ b/docs/final-presentation.pptx
@@ -2178,8 +2178,8 @@
   <dgm:cxnLst>
     <dgm:cxn modelId="{0E20FF05-233D-9B40-8362-974BF69DC0EF}" type="presOf" srcId="{F87D24F9-FF4F-7549-B6A3-D1B95ABB5958}" destId="{1DD12ABA-0634-F649-9B1A-DC4D37B46BF1}" srcOrd="0" destOrd="0" presId="urn:microsoft.com/office/officeart/2005/8/layout/vList2"/>
     <dgm:cxn modelId="{9506BB2C-4ABA-BE4D-893E-DF6DD2B471CD}" srcId="{F87D24F9-FF4F-7549-B6A3-D1B95ABB5958}" destId="{49AB5B44-B890-B04C-B026-B86A4E700BAF}" srcOrd="3" destOrd="0" parTransId="{06CC8F03-3F23-9C4F-9643-EF79EBBB9BFC}" sibTransId="{7E4D2B67-13A2-F745-B01E-0AA589E8D2FB}"/>
+    <dgm:cxn modelId="{CFD5CC67-FCBB-194E-B2F7-BD72D1F0795D}" type="presOf" srcId="{E15CECD0-F9AD-734F-89C5-C4CCCF9C1925}" destId="{5E47F58B-E774-B142-84A7-D4263EA16CAC}" srcOrd="0" destOrd="0" presId="urn:microsoft.com/office/officeart/2005/8/layout/vList2"/>
     <dgm:cxn modelId="{A6026648-4701-BB49-845E-26A024567F43}" srcId="{F87D24F9-FF4F-7549-B6A3-D1B95ABB5958}" destId="{E15CECD0-F9AD-734F-89C5-C4CCCF9C1925}" srcOrd="1" destOrd="0" parTransId="{1F0BC59E-0379-254C-B409-BD560463E491}" sibTransId="{57F3C453-2BF9-0247-A94B-271738015166}"/>
-    <dgm:cxn modelId="{CFD5CC67-FCBB-194E-B2F7-BD72D1F0795D}" type="presOf" srcId="{E15CECD0-F9AD-734F-89C5-C4CCCF9C1925}" destId="{5E47F58B-E774-B142-84A7-D4263EA16CAC}" srcOrd="0" destOrd="0" presId="urn:microsoft.com/office/officeart/2005/8/layout/vList2"/>
     <dgm:cxn modelId="{B82FE28D-81A1-514C-ADF3-43F5800C92F9}" srcId="{F87D24F9-FF4F-7549-B6A3-D1B95ABB5958}" destId="{DDCDCC64-7C40-4B4B-A9DE-7631E262C1ED}" srcOrd="2" destOrd="0" parTransId="{BFC90EA5-DAE7-BC41-A45D-F83662BBBF9C}" sibTransId="{3432B65C-D8CB-FA40-9065-104D1E2992F5}"/>
     <dgm:cxn modelId="{81C88F8E-0F5D-9840-BFA7-F16592281EDD}" type="presOf" srcId="{49AB5B44-B890-B04C-B026-B86A4E700BAF}" destId="{0A194821-F26A-8340-BEB3-3B39CE0C0C2A}" srcOrd="0" destOrd="0" presId="urn:microsoft.com/office/officeart/2005/8/layout/vList2"/>
     <dgm:cxn modelId="{76BA9BB0-7080-3043-8890-F20D48B6A204}" type="presOf" srcId="{DDCDCC64-7C40-4B4B-A9DE-7631E262C1ED}" destId="{1FC2D9C7-F561-A140-80B3-38AA250F4ED3}" srcOrd="0" destOrd="0" presId="urn:microsoft.com/office/officeart/2005/8/layout/vList2"/>
@@ -3024,9 +3024,9 @@
     <dgm:cxn modelId="{FE8BD825-6B1F-BD41-9A50-5E3A1EADA8B7}" srcId="{C5CB9A22-3683-F941-A424-8330C2EAE038}" destId="{ABE5EB6A-D765-0445-9A4B-14B363F2B7B4}" srcOrd="0" destOrd="0" parTransId="{49B25C23-D199-5145-A357-69F3568D9C31}" sibTransId="{E316537E-49AF-5C41-B39F-DCF696ECEC0B}"/>
     <dgm:cxn modelId="{08F14C32-5B36-1A40-AB30-E71703DFA022}" type="presOf" srcId="{C4434C44-0A3B-5146-B2CB-7ECA0DF842EF}" destId="{6B20C442-531A-3C4A-B762-BBE8ADB5D9BF}" srcOrd="0" destOrd="0" presId="urn:microsoft.com/office/officeart/2005/8/layout/lProcess3"/>
     <dgm:cxn modelId="{B1D8AF36-DF1C-6C4E-9677-941E1079F2D5}" srcId="{D3398E48-3275-124E-AC06-5E9108890A89}" destId="{DF55D552-F233-754B-8C4A-83348C9E412C}" srcOrd="1" destOrd="0" parTransId="{E78CAAD2-808F-CB40-82CC-0D268182026A}" sibTransId="{36098520-AA9A-544B-8117-9EBE800373B2}"/>
-    <dgm:cxn modelId="{330E8E44-67B3-6148-98FB-126CF9F4DA8D}" type="presOf" srcId="{D3398E48-3275-124E-AC06-5E9108890A89}" destId="{4F04F93E-8444-5844-8F4E-0660634429D2}" srcOrd="0" destOrd="0" presId="urn:microsoft.com/office/officeart/2005/8/layout/lProcess3"/>
     <dgm:cxn modelId="{66023A5C-CCCB-8D44-A6A1-F20B00CE4373}" type="presOf" srcId="{F2E9435A-61E1-E94F-A488-19BE8FAD0884}" destId="{6CDFAF3D-1467-7042-B4CD-7349943C935E}" srcOrd="0" destOrd="0" presId="urn:microsoft.com/office/officeart/2005/8/layout/lProcess3"/>
     <dgm:cxn modelId="{CCB0A25D-1C12-204C-83E6-0A5E09CCBF9E}" srcId="{C5CB9A22-3683-F941-A424-8330C2EAE038}" destId="{CC7342D0-AF7D-E144-BFBD-D373CCA86CA8}" srcOrd="1" destOrd="0" parTransId="{60DF9A4D-3CE0-7D45-926C-8166819744C0}" sibTransId="{E9DCF3E5-C996-7D4D-8D19-90837A3B7BDD}"/>
+    <dgm:cxn modelId="{330E8E44-67B3-6148-98FB-126CF9F4DA8D}" type="presOf" srcId="{D3398E48-3275-124E-AC06-5E9108890A89}" destId="{4F04F93E-8444-5844-8F4E-0660634429D2}" srcOrd="0" destOrd="0" presId="urn:microsoft.com/office/officeart/2005/8/layout/lProcess3"/>
     <dgm:cxn modelId="{D9FA1D69-A987-F644-9CE1-1F23FEF35720}" srcId="{C5CB9A22-3683-F941-A424-8330C2EAE038}" destId="{2B567922-A26D-C340-8522-3AA4D87C723A}" srcOrd="2" destOrd="0" parTransId="{516F8C0F-F091-6F4F-99C6-321817D378DC}" sibTransId="{C5237596-8967-2D4B-AE8D-7F2A6D02FBD1}"/>
     <dgm:cxn modelId="{0B130971-BF44-154D-8D05-C705663D4059}" type="presOf" srcId="{54DA47AC-B1F4-F641-9D16-7100BAAE5D4D}" destId="{A26DDB8B-AAD1-1142-9B4D-0AF9027AF54C}" srcOrd="0" destOrd="0" presId="urn:microsoft.com/office/officeart/2005/8/layout/lProcess3"/>
     <dgm:cxn modelId="{5B7DEF71-A203-3A45-9F9C-3B5B31F7B413}" type="presOf" srcId="{69E84C7A-FDD7-2C4E-BBD0-D2F4E7D43B44}" destId="{3E341B9D-76C4-0A4E-B6C1-F7D45F1B1F1A}" srcOrd="0" destOrd="0" presId="urn:microsoft.com/office/officeart/2005/8/layout/lProcess3"/>
@@ -7441,7 +7441,7 @@
           <a:p>
             <a:fld id="{484FEB8E-57CB-43C0-BEF7-4F4116A5252C}" type="datetimeFigureOut">
               <a:rPr lang="de-CH" smtClean="0"/>
-              <a:t>07.06.26</a:t>
+              <a:t>10.06.2026</a:t>
             </a:fld>
             <a:endParaRPr lang="de-CH"/>
           </a:p>
@@ -12555,12 +12555,8 @@
               <a:buChar char="•"/>
             </a:pPr>
             <a:r>
-              <a:rPr lang="en-US" dirty="0" err="1"/>
-              <a:t>Demnstrates</a:t>
-            </a:r>
-            <a:r>
               <a:rPr lang="en-US" dirty="0"/>
-              <a:t> real OS mechanisms on real hardware</a:t>
+              <a:t>Demonstrates real OS mechanisms on real hardware</a:t>
             </a:r>
           </a:p>
           <a:p>
@@ -13561,7 +13557,7 @@
             </a:pPr>
             <a:r>
               <a:rPr lang="en-US" b="1" dirty="0" err="1"/>
-              <a:t>Raspberyy</a:t>
+              <a:t>Raspbery</a:t>
             </a:r>
             <a:r>
               <a:rPr lang="en-US" b="1" dirty="0"/>

</xml_diff>